<commit_message>
Met à jour l'architecture : relais nginx, auth, Mailpit dans le schéma et les livrables
</commit_message>
<xml_diff>
--- a/docs/Architecture-RESILIENCE-ALPHA.pptx
+++ b/docs/Architecture-RESILIENCE-ALPHA.pptx
@@ -109,7 +109,7 @@
   <p:extLst>
     <p:ext uri="{521415D9-36F7-43E2-AB2F-B90AF26B5E84}">
       <p14:sectionLst xmlns:p14="http://schemas.microsoft.com/office/powerpoint/2010/main">
-        <p14:section name="Architecture" id="{1e0949cc-2992-3f60-9460-c4984fb809b3}">
+        <p14:section name="Architecture" id="{a4f89451-03ac-a1b9-f514-75ff61224e9a}">
           <p14:sldIdLst>
             <p14:sldId id="256"/>
             <p14:sldId id="257"/>
@@ -1655,8 +1655,8 @@
         </p:blipFill>
         <p:spPr>
           <a:xfrm>
-            <a:off x="1115568" y="960120"/>
-            <a:ext cx="9966960" cy="5788152"/>
+            <a:off x="1508760" y="914400"/>
+            <a:ext cx="9116568" cy="5760720"/>
           </a:xfrm>
           <a:prstGeom prst="rect">
             <a:avLst/>
@@ -2960,7 +2960,7 @@
                   <a:schemeClr val="tx1"/>
                 </a:solidFill>
               </a:rPr>
-              <a:t>Docker Compose · orchestration</a:t>
+              <a:t>Compose &amp; Swarm · orchestration</a:t>
             </a:r>
             <a:endParaRPr lang="en-US" sz="1050" dirty="0"/>
           </a:p>

</xml_diff>